<commit_message>
Usar QR fijo de GitHub Pages en vez de IP local
</commit_message>
<xml_diff>
--- a/Presentacion-Casa-Cultura-Filadelfia.pptx
+++ b/Presentacion-Casa-Cultura-Filadelfia.pptx
@@ -5476,7 +5476,23 @@
                 </a:solidFill>
                 <a:latin typeface="Calibri"/>
               </a:rPr>
-              <a:t>⚠ Debes estar conectado a la misma red WiFi que esta computadora.</a:t>
+              <a:t>Funciona desde cualquier celular con internet, en cualquier momento.</a:t>
+            </a:r>
+          </a:p>
+          <a:p>
+            <a:pPr algn="l">
+              <a:spcBef>
+                <a:spcPts val="1000"/>
+              </a:spcBef>
+            </a:pPr>
+            <a:r>
+              <a:rPr sz="1250" b="0" i="0">
+                <a:solidFill>
+                  <a:srgbClr val="E8DCC4"/>
+                </a:solidFill>
+                <a:latin typeface="Calibri"/>
+              </a:rPr>
+              <a:t>kendallquirosalvarez-prog.github.io/museo-casa-cultura-filadelfia</a:t>
             </a:r>
           </a:p>
         </p:txBody>

</xml_diff>